<commit_message>
fix(aan): sync Vol VII Book 05 derivatives + status table to the refreshed Date Codes
The derivative-freshness and status-drift gates caught the two
downstream artifacts of the Phase 0 scrub's Date Code refresh, exactly
as designed:

- decks/Vol_VII_Book_05.yaml date_code synced to the qmd (spec section 1),
  then the tracked .pptx regenerated via `uiao generate aan-deck` and the
  tracked .docx re-rendered via `quarto render --to docx` — all 24
  tracked derivative pairs now carry their source's Date Code.
- docs/data/customer-documents-status.md regenerated (frontmatter dates
  feed the derived status table).

Co-Authored-By: Claude Fable 5 <noreply@anthropic.com>
</commit_message>
<xml_diff>
--- a/docs/customer-documents/federal-aan-series/Vol_VII_Book_05_FedAAN_ServiceNow_Compliance_App.pptx
+++ b/docs/customer-documents/federal-aan-series/Vol_VII_Book_05_FedAAN_ServiceNow_Compliance_App.pptx
@@ -586,7 +586,7 @@
           <a:lstStyle/>
           <a:p>
             <a:r>
-              <a:t>Motivate the deployable. Everything-as-code (Vol VI Book 00) means the app is an importable update set, its control map is machine-readable data, and its behavior is covered by runnable ATF tests. Set expectations honestly: this is a starter skeleton named x_ssa_fed_compliance — reviewed, completed per tenant, and tested in sub-prod before any production use, exactly like the DDI app skeleton already in the repo.</a:t>
+              <a:t>Motivate the deployable. Everything-as-code (Vol VI Book 00) means the app is an importable update set, its control map is machine-readable data, and its behavior is covered by runnable ATF tests. Set expectations honestly: this is a starter skeleton named x_fed_compliance — reviewed, completed per tenant, and tested in sub-prod before any production use, exactly like the DDI app skeleton already in the repo.</a:t>
             </a:r>
           </a:p>
         </p:txBody>
@@ -4877,7 +4877,7 @@
                 </a:solidFill>
                 <a:latin typeface="Arial"/>
               </a:rPr>
-              <a:t>Date Code: 2026-07-14 11:56 ET</a:t>
+              <a:t>Date Code: 2026-07-18 00:33 ET</a:t>
             </a:r>
           </a:p>
         </p:txBody>
@@ -5065,7 +5065,7 @@
                 </a:solidFill>
                 <a:latin typeface="Arial"/>
               </a:rPr>
-              <a:t>The ServiceNow Compliance App · Date Code: 2026-07-14 11:56 ET</a:t>
+              <a:t>The ServiceNow Compliance App · Date Code: 2026-07-18 00:33 ET</a:t>
             </a:r>
           </a:p>
         </p:txBody>
@@ -5288,7 +5288,7 @@
                 </a:solidFill>
                 <a:latin typeface="Arial"/>
               </a:rPr>
-              <a:t>The ServiceNow Compliance App · Date Code: 2026-07-14 11:56 ET</a:t>
+              <a:t>The ServiceNow Compliance App · Date Code: 2026-07-18 00:33 ET</a:t>
             </a:r>
           </a:p>
         </p:txBody>
@@ -6195,7 +6195,7 @@
                 </a:solidFill>
                 <a:latin typeface="Arial"/>
               </a:rPr>
-              <a:t>The ServiceNow Compliance App · Date Code: 2026-07-14 11:56 ET</a:t>
+              <a:t>The ServiceNow Compliance App · Date Code: 2026-07-18 00:33 ET</a:t>
             </a:r>
           </a:p>
         </p:txBody>
@@ -7057,7 +7057,7 @@
                 </a:solidFill>
                 <a:latin typeface="Arial"/>
               </a:rPr>
-              <a:t>Create x_ssa_fed_compliance (or import the update set) in a sub-prod instance; add the three Script Includes and the two REST Messages.
+              <a:t>Create x_fed_compliance (or import the update set) in a sub-prod instance; add the three Script Includes and the two REST Messages.
 </a:t>
             </a:r>
           </a:p>
@@ -7189,7 +7189,7 @@
                 </a:solidFill>
                 <a:latin typeface="Arial"/>
               </a:rPr>
-              <a:t>The ServiceNow Compliance App · Date Code: 2026-07-14 11:56 ET</a:t>
+              <a:t>The ServiceNow Compliance App · Date Code: 2026-07-18 00:33 ET</a:t>
             </a:r>
           </a:p>
         </p:txBody>
@@ -8183,7 +8183,7 @@
                 </a:solidFill>
                 <a:latin typeface="Arial"/>
               </a:rPr>
-              <a:t>The ServiceNow Compliance App · Date Code: 2026-07-14 11:56 ET</a:t>
+              <a:t>The ServiceNow Compliance App · Date Code: 2026-07-18 00:33 ET</a:t>
             </a:r>
           </a:p>
         </p:txBody>
@@ -9177,7 +9177,7 @@
                 </a:solidFill>
                 <a:latin typeface="Arial"/>
               </a:rPr>
-              <a:t>The ServiceNow Compliance App · Date Code: 2026-07-14 11:56 ET</a:t>
+              <a:t>The ServiceNow Compliance App · Date Code: 2026-07-18 00:33 ET</a:t>
             </a:r>
           </a:p>
         </p:txBody>
@@ -10171,7 +10171,7 @@
                 </a:solidFill>
                 <a:latin typeface="Arial"/>
               </a:rPr>
-              <a:t>The ServiceNow Compliance App · Date Code: 2026-07-14 11:56 ET</a:t>
+              <a:t>The ServiceNow Compliance App · Date Code: 2026-07-18 00:33 ET</a:t>
             </a:r>
           </a:p>
         </p:txBody>
@@ -10829,7 +10829,7 @@
                 </a:solidFill>
                 <a:latin typeface="Arial"/>
               </a:rPr>
-              <a:t>The ServiceNow Compliance App · Date Code: 2026-07-14 11:56 ET</a:t>
+              <a:t>The ServiceNow Compliance App · Date Code: 2026-07-18 00:33 ET</a:t>
             </a:r>
           </a:p>
         </p:txBody>

</xml_diff>